<commit_message>
submission: pitch deck v2 - add milestones slide (27B on A100, custom stack, live forecast)
</commit_message>
<xml_diff>
--- a/ModuleWarden-deck.pptx
+++ b/ModuleWarden-deck.pptx
@@ -19,6 +19,7 @@
     <p:sldId id="267" r:id="rId18"/>
     <p:sldId id="268" r:id="rId19"/>
     <p:sldId id="269" r:id="rId20"/>
+    <p:sldId id="270" r:id="rId21"/>
   </p:sldIdLst>
   <p:sldSz cx="12191695" cy="6858000" type="screen4x3"/>
   <p:notesSz cx="6858000" cy="9144000"/>
@@ -4581,7 +4582,7 @@
                 </a:solidFill>
                 <a:latin typeface="Consolas"/>
               </a:rPr>
-              <a:t>CLOSE</a:t>
+              <a:t>BUILT AT THE HACKATHON</a:t>
             </a:r>
           </a:p>
         </p:txBody>
@@ -4595,7 +4596,7 @@
         <p:spPr>
           <a:xfrm>
             <a:off x="713232" y="1051560"/>
-            <a:ext cx="10698480" cy="1463040"/>
+            <a:ext cx="10698480" cy="914400"/>
           </a:xfrm>
           <a:prstGeom prst="rect">
             <a:avLst/>
@@ -4610,7 +4611,7 @@
           <a:p>
             <a:pPr algn="l">
               <a:lnSpc>
-                <a:spcPct val="102000"/>
+                <a:spcPct val="100000"/>
               </a:lnSpc>
             </a:pPr>
             <a:r>
@@ -4620,7 +4621,7 @@
                 </a:solidFill>
                 <a:latin typeface="Arial"/>
               </a:rPr>
-              <a:t>Grow a forecast into a new domain without it lying to you.</a:t>
+              <a:t>What we shipped.</a:t>
             </a:r>
           </a:p>
         </p:txBody>
@@ -4633,8 +4634,8 @@
         </p:nvSpPr>
         <p:spPr>
           <a:xfrm>
-            <a:off x="731520" y="2651760"/>
-            <a:ext cx="10698480" cy="3108960"/>
+            <a:off x="731520" y="2240280"/>
+            <a:ext cx="10881360" cy="3931920"/>
           </a:xfrm>
           <a:prstGeom prst="rect">
             <a:avLst/>
@@ -4642,24 +4643,230 @@
           <a:noFill/>
         </p:spPr>
         <p:txBody>
-          <a:bodyPr wrap="square" anchor="t">
+          <a:bodyPr wrap="square">
             <a:spAutoFit/>
           </a:bodyPr>
           <a:lstStyle/>
           <a:p>
-            <a:pPr algn="l">
-              <a:lnSpc>
-                <a:spcPct val="118000"/>
-              </a:lnSpc>
-            </a:pPr>
-            <a:r>
-              <a:rPr sz="2100" b="0">
+            <a:pPr>
+              <a:lnSpc>
+                <a:spcPct val="105000"/>
+              </a:lnSpc>
+              <a:spcAft>
+                <a:spcPts val="1100"/>
+              </a:spcAft>
+            </a:pPr>
+            <a:r>
+              <a:rPr sz="1800" b="1">
+                <a:solidFill>
+                  <a:srgbClr val="34D399"/>
+                </a:solidFill>
+                <a:latin typeface="Arial"/>
+              </a:rPr>
+              <a:t>▪  </a:t>
+            </a:r>
+            <a:r>
+              <a:rPr sz="1800" b="1">
+                <a:solidFill>
+                  <a:srgbClr val="F1F5F9"/>
+                </a:solidFill>
+                <a:latin typeface="Arial"/>
+              </a:rPr>
+              <a:t>A Jan-2026 27B on 2023 silicon.  </a:t>
+            </a:r>
+            <a:r>
+              <a:rPr sz="1800">
                 <a:solidFill>
                   <a:srgbClr val="ADBACC"/>
                 </a:solidFill>
                 <a:latin typeface="Arial"/>
               </a:rPr>
-              <a:t>Sybilion says the domain is yours. We kept what the forecast earned (trajectory ranking), gated what it could not (the full audit pipeline owns the verdict), and conceded the rest with the data.</a:t>
+              <a:t>Fine-tuned a hybrid-attention 27B end to end on Leonardo (4x A100), bridging the CUDA and llama.cpp version gap with a custom-built stack. Validation loss 0.21, about 43 minutes wall.</a:t>
+            </a:r>
+          </a:p>
+          <a:p>
+            <a:pPr>
+              <a:lnSpc>
+                <a:spcPct val="105000"/>
+              </a:lnSpc>
+              <a:spcAft>
+                <a:spcPts val="1100"/>
+              </a:spcAft>
+            </a:pPr>
+            <a:r>
+              <a:rPr sz="1800" b="1">
+                <a:solidFill>
+                  <a:srgbClr val="34D399"/>
+                </a:solidFill>
+                <a:latin typeface="Arial"/>
+              </a:rPr>
+              <a:t>▪  </a:t>
+            </a:r>
+            <a:r>
+              <a:rPr sz="1800" b="1">
+                <a:solidFill>
+                  <a:srgbClr val="F1F5F9"/>
+                </a:solidFill>
+                <a:latin typeface="Arial"/>
+              </a:rPr>
+              <a:t>Published.  </a:t>
+            </a:r>
+            <a:r>
+              <a:rPr sz="1800">
+                <a:solidFill>
+                  <a:srgbClr val="ADBACC"/>
+                </a:solidFill>
+                <a:latin typeface="Arial"/>
+              </a:rPr>
+              <a:t>The fine-tuned auditor LoRA is live on Hugging Face.</a:t>
+            </a:r>
+          </a:p>
+          <a:p>
+            <a:pPr>
+              <a:lnSpc>
+                <a:spcPct val="105000"/>
+              </a:lnSpc>
+              <a:spcAft>
+                <a:spcPts val="1100"/>
+              </a:spcAft>
+            </a:pPr>
+            <a:r>
+              <a:rPr sz="1800" b="1">
+                <a:solidFill>
+                  <a:srgbClr val="34D399"/>
+                </a:solidFill>
+                <a:latin typeface="Arial"/>
+              </a:rPr>
+              <a:t>▪  </a:t>
+            </a:r>
+            <a:r>
+              <a:rPr sz="1800" b="1">
+                <a:solidFill>
+                  <a:srgbClr val="F1F5F9"/>
+                </a:solidFill>
+                <a:latin typeface="Arial"/>
+              </a:rPr>
+              <a:t>Code-bearing corpus.  </a:t>
+            </a:r>
+            <a:r>
+              <a:rPr sz="1800">
+                <a:solidFill>
+                  <a:srgbClr val="ADBACC"/>
+                </a:solidFill>
+                <a:latin typeface="Arial"/>
+              </a:rPr>
+              <a:t>We audit sanitized diff excerpts and capability deltas, not just package metadata.</a:t>
+            </a:r>
+          </a:p>
+          <a:p>
+            <a:pPr>
+              <a:lnSpc>
+                <a:spcPct val="105000"/>
+              </a:lnSpc>
+              <a:spcAft>
+                <a:spcPts val="1100"/>
+              </a:spcAft>
+            </a:pPr>
+            <a:r>
+              <a:rPr sz="1800" b="1">
+                <a:solidFill>
+                  <a:srgbClr val="34D399"/>
+                </a:solidFill>
+                <a:latin typeface="Arial"/>
+              </a:rPr>
+              <a:t>▪  </a:t>
+            </a:r>
+            <a:r>
+              <a:rPr sz="1800" b="1">
+                <a:solidFill>
+                  <a:srgbClr val="F1F5F9"/>
+                </a:solidFill>
+                <a:latin typeface="Arial"/>
+              </a:rPr>
+              <a:t>Honest pivot.  </a:t>
+            </a:r>
+            <a:r>
+              <a:rPr sz="1800">
+                <a:solidFill>
+                  <a:srgbClr val="ADBACC"/>
+                </a:solidFill>
+                <a:latin typeface="Arial"/>
+              </a:rPr>
+              <a:t>The forecast cannot detect a dying package (AUROC 0.54), so we made it rank review order and kept the finding.</a:t>
+            </a:r>
+          </a:p>
+          <a:p>
+            <a:pPr>
+              <a:lnSpc>
+                <a:spcPct val="105000"/>
+              </a:lnSpc>
+              <a:spcAft>
+                <a:spcPts val="1100"/>
+              </a:spcAft>
+            </a:pPr>
+            <a:r>
+              <a:rPr sz="1800" b="1">
+                <a:solidFill>
+                  <a:srgbClr val="34D399"/>
+                </a:solidFill>
+                <a:latin typeface="Arial"/>
+              </a:rPr>
+              <a:t>▪  </a:t>
+            </a:r>
+            <a:r>
+              <a:rPr sz="1800" b="1">
+                <a:solidFill>
+                  <a:srgbClr val="F1F5F9"/>
+                </a:solidFill>
+                <a:latin typeface="Arial"/>
+              </a:rPr>
+              <a:t>Live at scale.  </a:t>
+            </a:r>
+            <a:r>
+              <a:rPr sz="1800">
+                <a:solidFill>
+                  <a:srgbClr val="ADBACC"/>
+                </a:solidFill>
+                <a:latin typeface="Arial"/>
+              </a:rPr>
+              <a:t>46 real npm packages forecasted through Sybilion: 18 routed to a human, 28 auto-cleared.</a:t>
+            </a:r>
+          </a:p>
+          <a:p>
+            <a:pPr>
+              <a:lnSpc>
+                <a:spcPct val="105000"/>
+              </a:lnSpc>
+              <a:spcAft>
+                <a:spcPts val="1100"/>
+              </a:spcAft>
+            </a:pPr>
+            <a:r>
+              <a:rPr sz="1800" b="1">
+                <a:solidFill>
+                  <a:srgbClr val="34D399"/>
+                </a:solidFill>
+                <a:latin typeface="Arial"/>
+              </a:rPr>
+              <a:t>▪  </a:t>
+            </a:r>
+            <a:r>
+              <a:rPr sz="1800" b="1">
+                <a:solidFill>
+                  <a:srgbClr val="F1F5F9"/>
+                </a:solidFill>
+                <a:latin typeface="Arial"/>
+              </a:rPr>
+              <a:t>Schema-valid auditor.  </a:t>
+            </a:r>
+            <a:r>
+              <a:rPr sz="1800">
+                <a:solidFill>
+                  <a:srgbClr val="ADBACC"/>
+                </a:solidFill>
+                <a:latin typeface="Arial"/>
+              </a:rPr>
+              <a:t>Valid every time on held-out dossiers, 94 percent narration fidelity, where the untuned base rambles.</a:t>
             </a:r>
           </a:p>
         </p:txBody>
@@ -4812,6 +5019,307 @@
         </p:nvSpPr>
         <p:spPr>
           <a:xfrm>
+            <a:off x="502920" y="640080"/>
+            <a:ext cx="82296" cy="457200"/>
+          </a:xfrm>
+          <a:prstGeom prst="rect">
+            <a:avLst/>
+          </a:prstGeom>
+          <a:solidFill>
+            <a:srgbClr val="34D399"/>
+          </a:solidFill>
+          <a:ln>
+            <a:noFill/>
+          </a:ln>
+          <a:effectLst/>
+        </p:spPr>
+        <p:style>
+          <a:lnRef idx="1">
+            <a:schemeClr val="accent1"/>
+          </a:lnRef>
+          <a:fillRef idx="3">
+            <a:schemeClr val="accent1"/>
+          </a:fillRef>
+          <a:effectRef idx="2">
+            <a:schemeClr val="accent1"/>
+          </a:effectRef>
+          <a:fontRef idx="minor">
+            <a:schemeClr val="lt1"/>
+          </a:fontRef>
+        </p:style>
+        <p:txBody>
+          <a:bodyPr rtlCol="0" anchor="ctr"/>
+          <a:lstStyle/>
+          <a:p>
+            <a:pPr algn="ctr"/>
+          </a:p>
+        </p:txBody>
+      </p:sp>
+      <p:sp>
+        <p:nvSpPr>
+          <p:cNvPr id="4" name="TextBox 3"/>
+          <p:cNvSpPr txBox="1"/>
+          <p:nvPr/>
+        </p:nvSpPr>
+        <p:spPr>
+          <a:xfrm>
+            <a:off x="731520" y="566928"/>
+            <a:ext cx="10058400" cy="365760"/>
+          </a:xfrm>
+          <a:prstGeom prst="rect">
+            <a:avLst/>
+          </a:prstGeom>
+          <a:noFill/>
+        </p:spPr>
+        <p:txBody>
+          <a:bodyPr wrap="square" anchor="t">
+            <a:spAutoFit/>
+          </a:bodyPr>
+          <a:lstStyle/>
+          <a:p>
+            <a:pPr algn="l">
+              <a:lnSpc>
+                <a:spcPct val="100000"/>
+              </a:lnSpc>
+            </a:pPr>
+            <a:r>
+              <a:rPr sz="1300" b="1">
+                <a:solidFill>
+                  <a:srgbClr val="34D399"/>
+                </a:solidFill>
+                <a:latin typeface="Consolas"/>
+              </a:rPr>
+              <a:t>CLOSE</a:t>
+            </a:r>
+          </a:p>
+        </p:txBody>
+      </p:sp>
+      <p:sp>
+        <p:nvSpPr>
+          <p:cNvPr id="5" name="TextBox 4"/>
+          <p:cNvSpPr txBox="1"/>
+          <p:nvPr/>
+        </p:nvSpPr>
+        <p:spPr>
+          <a:xfrm>
+            <a:off x="713232" y="1051560"/>
+            <a:ext cx="10698480" cy="1463040"/>
+          </a:xfrm>
+          <a:prstGeom prst="rect">
+            <a:avLst/>
+          </a:prstGeom>
+          <a:noFill/>
+        </p:spPr>
+        <p:txBody>
+          <a:bodyPr wrap="square" anchor="t">
+            <a:spAutoFit/>
+          </a:bodyPr>
+          <a:lstStyle/>
+          <a:p>
+            <a:pPr algn="l">
+              <a:lnSpc>
+                <a:spcPct val="102000"/>
+              </a:lnSpc>
+            </a:pPr>
+            <a:r>
+              <a:rPr sz="3800" b="1">
+                <a:solidFill>
+                  <a:srgbClr val="F1F5F9"/>
+                </a:solidFill>
+                <a:latin typeface="Arial"/>
+              </a:rPr>
+              <a:t>Grow a forecast into a new domain without it lying to you.</a:t>
+            </a:r>
+          </a:p>
+        </p:txBody>
+      </p:sp>
+      <p:sp>
+        <p:nvSpPr>
+          <p:cNvPr id="6" name="TextBox 5"/>
+          <p:cNvSpPr txBox="1"/>
+          <p:nvPr/>
+        </p:nvSpPr>
+        <p:spPr>
+          <a:xfrm>
+            <a:off x="731520" y="2651760"/>
+            <a:ext cx="10698480" cy="3108960"/>
+          </a:xfrm>
+          <a:prstGeom prst="rect">
+            <a:avLst/>
+          </a:prstGeom>
+          <a:noFill/>
+        </p:spPr>
+        <p:txBody>
+          <a:bodyPr wrap="square" anchor="t">
+            <a:spAutoFit/>
+          </a:bodyPr>
+          <a:lstStyle/>
+          <a:p>
+            <a:pPr algn="l">
+              <a:lnSpc>
+                <a:spcPct val="118000"/>
+              </a:lnSpc>
+            </a:pPr>
+            <a:r>
+              <a:rPr sz="2100" b="0">
+                <a:solidFill>
+                  <a:srgbClr val="ADBACC"/>
+                </a:solidFill>
+                <a:latin typeface="Arial"/>
+              </a:rPr>
+              <a:t>Sybilion says the domain is yours. We kept what the forecast earned (trajectory ranking), gated what it could not (the full audit pipeline owns the verdict), and conceded the rest with the data.</a:t>
+            </a:r>
+          </a:p>
+        </p:txBody>
+      </p:sp>
+      <p:sp>
+        <p:nvSpPr>
+          <p:cNvPr id="7" name="TextBox 6"/>
+          <p:cNvSpPr txBox="1"/>
+          <p:nvPr/>
+        </p:nvSpPr>
+        <p:spPr>
+          <a:xfrm>
+            <a:off x="502920" y="6400800"/>
+            <a:ext cx="8229600" cy="365760"/>
+          </a:xfrm>
+          <a:prstGeom prst="rect">
+            <a:avLst/>
+          </a:prstGeom>
+          <a:noFill/>
+        </p:spPr>
+        <p:txBody>
+          <a:bodyPr wrap="square" anchor="t">
+            <a:spAutoFit/>
+          </a:bodyPr>
+          <a:lstStyle/>
+          <a:p>
+            <a:pPr algn="l">
+              <a:lnSpc>
+                <a:spcPct val="100000"/>
+              </a:lnSpc>
+            </a:pPr>
+            <a:r>
+              <a:rPr sz="1000" b="0">
+                <a:solidFill>
+                  <a:srgbClr val="64748B"/>
+                </a:solidFill>
+                <a:latin typeface="Consolas"/>
+              </a:rPr>
+              <a:t>ModuleWarden  ·  Zero-One Hack Vienna 2026  ·  Forecast track</a:t>
+            </a:r>
+          </a:p>
+        </p:txBody>
+      </p:sp>
+      <p:sp>
+        <p:nvSpPr>
+          <p:cNvPr id="8" name="TextBox 7"/>
+          <p:cNvSpPr txBox="1"/>
+          <p:nvPr/>
+        </p:nvSpPr>
+        <p:spPr>
+          <a:xfrm>
+            <a:off x="11155680" y="6400800"/>
+            <a:ext cx="731520" cy="365760"/>
+          </a:xfrm>
+          <a:prstGeom prst="rect">
+            <a:avLst/>
+          </a:prstGeom>
+          <a:noFill/>
+        </p:spPr>
+        <p:txBody>
+          <a:bodyPr wrap="square" anchor="t">
+            <a:spAutoFit/>
+          </a:bodyPr>
+          <a:lstStyle/>
+          <a:p>
+            <a:pPr algn="r">
+              <a:lnSpc>
+                <a:spcPct val="100000"/>
+              </a:lnSpc>
+            </a:pPr>
+            <a:r>
+              <a:rPr sz="1000" b="0">
+                <a:solidFill>
+                  <a:srgbClr val="64748B"/>
+                </a:solidFill>
+                <a:latin typeface="Consolas"/>
+              </a:rPr>
+              <a:t>14</a:t>
+            </a:r>
+          </a:p>
+        </p:txBody>
+      </p:sp>
+    </p:spTree>
+  </p:cSld>
+  <p:clrMapOvr>
+    <a:masterClrMapping/>
+  </p:clrMapOvr>
+</p:sld>
+</file>
+
+<file path=ppt/slides/slide15.xml><?xml version="1.0" encoding="utf-8"?>
+<p:sld xmlns:a="http://schemas.openxmlformats.org/drawingml/2006/main" xmlns:p="http://schemas.openxmlformats.org/presentationml/2006/main" xmlns:r="http://schemas.openxmlformats.org/officeDocument/2006/relationships">
+  <p:cSld>
+    <p:spTree>
+      <p:nvGrpSpPr>
+        <p:cNvPr id="1" name=""/>
+        <p:cNvGrpSpPr/>
+        <p:nvPr/>
+      </p:nvGrpSpPr>
+      <p:grpSpPr/>
+      <p:sp>
+        <p:nvSpPr>
+          <p:cNvPr id="2" name="Rectangle 1"/>
+          <p:cNvSpPr/>
+          <p:nvPr/>
+        </p:nvSpPr>
+        <p:spPr>
+          <a:xfrm>
+            <a:off x="0" y="0"/>
+            <a:ext cx="12191695" cy="6858000"/>
+          </a:xfrm>
+          <a:prstGeom prst="rect">
+            <a:avLst/>
+          </a:prstGeom>
+          <a:solidFill>
+            <a:srgbClr val="070B16"/>
+          </a:solidFill>
+          <a:ln>
+            <a:noFill/>
+          </a:ln>
+          <a:effectLst/>
+        </p:spPr>
+        <p:style>
+          <a:lnRef idx="1">
+            <a:schemeClr val="accent1"/>
+          </a:lnRef>
+          <a:fillRef idx="3">
+            <a:schemeClr val="accent1"/>
+          </a:fillRef>
+          <a:effectRef idx="2">
+            <a:schemeClr val="accent1"/>
+          </a:effectRef>
+          <a:fontRef idx="minor">
+            <a:schemeClr val="lt1"/>
+          </a:fontRef>
+        </p:style>
+        <p:txBody>
+          <a:bodyPr rtlCol="0" anchor="ctr"/>
+          <a:lstStyle/>
+          <a:p>
+            <a:pPr algn="ctr"/>
+          </a:p>
+        </p:txBody>
+      </p:sp>
+      <p:sp>
+        <p:nvSpPr>
+          <p:cNvPr id="3" name="Rectangle 2"/>
+          <p:cNvSpPr/>
+          <p:nvPr/>
+        </p:nvSpPr>
+        <p:spPr>
+          <a:xfrm>
             <a:off x="0" y="3108960"/>
             <a:ext cx="12191695" cy="45720"/>
           </a:xfrm>
@@ -5057,7 +5565,7 @@
                 </a:solidFill>
                 <a:latin typeface="Consolas"/>
               </a:rPr>
-              <a:t>14</a:t>
+              <a:t>15</a:t>
             </a:r>
           </a:p>
         </p:txBody>

</xml_diff>

<commit_message>
submission: add MILESTONES.md; deck back to clean 14-slide pitch (milestones live in the .md)
</commit_message>
<xml_diff>
--- a/ModuleWarden-deck.pptx
+++ b/ModuleWarden-deck.pptx
@@ -19,7 +19,6 @@
     <p:sldId id="267" r:id="rId18"/>
     <p:sldId id="268" r:id="rId19"/>
     <p:sldId id="269" r:id="rId20"/>
-    <p:sldId id="270" r:id="rId21"/>
   </p:sldIdLst>
   <p:sldSz cx="12191695" cy="6858000" type="screen4x3"/>
   <p:notesSz cx="6858000" cy="9144000"/>
@@ -4582,7 +4581,7 @@
                 </a:solidFill>
                 <a:latin typeface="Consolas"/>
               </a:rPr>
-              <a:t>BUILT AT THE HACKATHON</a:t>
+              <a:t>CLOSE</a:t>
             </a:r>
           </a:p>
         </p:txBody>
@@ -4596,7 +4595,7 @@
         <p:spPr>
           <a:xfrm>
             <a:off x="713232" y="1051560"/>
-            <a:ext cx="10698480" cy="914400"/>
+            <a:ext cx="10698480" cy="1463040"/>
           </a:xfrm>
           <a:prstGeom prst="rect">
             <a:avLst/>
@@ -4611,7 +4610,7 @@
           <a:p>
             <a:pPr algn="l">
               <a:lnSpc>
-                <a:spcPct val="100000"/>
+                <a:spcPct val="102000"/>
               </a:lnSpc>
             </a:pPr>
             <a:r>
@@ -4621,7 +4620,7 @@
                 </a:solidFill>
                 <a:latin typeface="Arial"/>
               </a:rPr>
-              <a:t>What we shipped.</a:t>
+              <a:t>Grow a forecast into a new domain without it lying to you.</a:t>
             </a:r>
           </a:p>
         </p:txBody>
@@ -4634,8 +4633,8 @@
         </p:nvSpPr>
         <p:spPr>
           <a:xfrm>
-            <a:off x="731520" y="2240280"/>
-            <a:ext cx="10881360" cy="3931920"/>
+            <a:off x="731520" y="2651760"/>
+            <a:ext cx="10698480" cy="3108960"/>
           </a:xfrm>
           <a:prstGeom prst="rect">
             <a:avLst/>
@@ -4643,230 +4642,24 @@
           <a:noFill/>
         </p:spPr>
         <p:txBody>
-          <a:bodyPr wrap="square">
+          <a:bodyPr wrap="square" anchor="t">
             <a:spAutoFit/>
           </a:bodyPr>
           <a:lstStyle/>
           <a:p>
-            <a:pPr>
+            <a:pPr algn="l">
               <a:lnSpc>
-                <a:spcPct val="105000"/>
+                <a:spcPct val="118000"/>
               </a:lnSpc>
-              <a:spcAft>
-                <a:spcPts val="1100"/>
-              </a:spcAft>
             </a:pPr>
             <a:r>
-              <a:rPr sz="1800" b="1">
-                <a:solidFill>
-                  <a:srgbClr val="34D399"/>
+              <a:rPr sz="2100" b="0">
+                <a:solidFill>
+                  <a:srgbClr val="ADBACC"/>
                 </a:solidFill>
                 <a:latin typeface="Arial"/>
               </a:rPr>
-              <a:t>▪  </a:t>
-            </a:r>
-            <a:r>
-              <a:rPr sz="1800" b="1">
-                <a:solidFill>
-                  <a:srgbClr val="F1F5F9"/>
-                </a:solidFill>
-                <a:latin typeface="Arial"/>
-              </a:rPr>
-              <a:t>A Jan-2026 27B on 2023 silicon.  </a:t>
-            </a:r>
-            <a:r>
-              <a:rPr sz="1800">
-                <a:solidFill>
-                  <a:srgbClr val="ADBACC"/>
-                </a:solidFill>
-                <a:latin typeface="Arial"/>
-              </a:rPr>
-              <a:t>Fine-tuned a hybrid-attention 27B end to end on Leonardo (4x A100), bridging the CUDA and llama.cpp version gap with a custom-built stack. Validation loss 0.21, about 43 minutes wall.</a:t>
-            </a:r>
-          </a:p>
-          <a:p>
-            <a:pPr>
-              <a:lnSpc>
-                <a:spcPct val="105000"/>
-              </a:lnSpc>
-              <a:spcAft>
-                <a:spcPts val="1100"/>
-              </a:spcAft>
-            </a:pPr>
-            <a:r>
-              <a:rPr sz="1800" b="1">
-                <a:solidFill>
-                  <a:srgbClr val="34D399"/>
-                </a:solidFill>
-                <a:latin typeface="Arial"/>
-              </a:rPr>
-              <a:t>▪  </a:t>
-            </a:r>
-            <a:r>
-              <a:rPr sz="1800" b="1">
-                <a:solidFill>
-                  <a:srgbClr val="F1F5F9"/>
-                </a:solidFill>
-                <a:latin typeface="Arial"/>
-              </a:rPr>
-              <a:t>Published.  </a:t>
-            </a:r>
-            <a:r>
-              <a:rPr sz="1800">
-                <a:solidFill>
-                  <a:srgbClr val="ADBACC"/>
-                </a:solidFill>
-                <a:latin typeface="Arial"/>
-              </a:rPr>
-              <a:t>The fine-tuned auditor LoRA is live on Hugging Face.</a:t>
-            </a:r>
-          </a:p>
-          <a:p>
-            <a:pPr>
-              <a:lnSpc>
-                <a:spcPct val="105000"/>
-              </a:lnSpc>
-              <a:spcAft>
-                <a:spcPts val="1100"/>
-              </a:spcAft>
-            </a:pPr>
-            <a:r>
-              <a:rPr sz="1800" b="1">
-                <a:solidFill>
-                  <a:srgbClr val="34D399"/>
-                </a:solidFill>
-                <a:latin typeface="Arial"/>
-              </a:rPr>
-              <a:t>▪  </a:t>
-            </a:r>
-            <a:r>
-              <a:rPr sz="1800" b="1">
-                <a:solidFill>
-                  <a:srgbClr val="F1F5F9"/>
-                </a:solidFill>
-                <a:latin typeface="Arial"/>
-              </a:rPr>
-              <a:t>Code-bearing corpus.  </a:t>
-            </a:r>
-            <a:r>
-              <a:rPr sz="1800">
-                <a:solidFill>
-                  <a:srgbClr val="ADBACC"/>
-                </a:solidFill>
-                <a:latin typeface="Arial"/>
-              </a:rPr>
-              <a:t>We audit sanitized diff excerpts and capability deltas, not just package metadata.</a:t>
-            </a:r>
-          </a:p>
-          <a:p>
-            <a:pPr>
-              <a:lnSpc>
-                <a:spcPct val="105000"/>
-              </a:lnSpc>
-              <a:spcAft>
-                <a:spcPts val="1100"/>
-              </a:spcAft>
-            </a:pPr>
-            <a:r>
-              <a:rPr sz="1800" b="1">
-                <a:solidFill>
-                  <a:srgbClr val="34D399"/>
-                </a:solidFill>
-                <a:latin typeface="Arial"/>
-              </a:rPr>
-              <a:t>▪  </a:t>
-            </a:r>
-            <a:r>
-              <a:rPr sz="1800" b="1">
-                <a:solidFill>
-                  <a:srgbClr val="F1F5F9"/>
-                </a:solidFill>
-                <a:latin typeface="Arial"/>
-              </a:rPr>
-              <a:t>Honest pivot.  </a:t>
-            </a:r>
-            <a:r>
-              <a:rPr sz="1800">
-                <a:solidFill>
-                  <a:srgbClr val="ADBACC"/>
-                </a:solidFill>
-                <a:latin typeface="Arial"/>
-              </a:rPr>
-              <a:t>The forecast cannot detect a dying package (AUROC 0.54), so we made it rank review order and kept the finding.</a:t>
-            </a:r>
-          </a:p>
-          <a:p>
-            <a:pPr>
-              <a:lnSpc>
-                <a:spcPct val="105000"/>
-              </a:lnSpc>
-              <a:spcAft>
-                <a:spcPts val="1100"/>
-              </a:spcAft>
-            </a:pPr>
-            <a:r>
-              <a:rPr sz="1800" b="1">
-                <a:solidFill>
-                  <a:srgbClr val="34D399"/>
-                </a:solidFill>
-                <a:latin typeface="Arial"/>
-              </a:rPr>
-              <a:t>▪  </a:t>
-            </a:r>
-            <a:r>
-              <a:rPr sz="1800" b="1">
-                <a:solidFill>
-                  <a:srgbClr val="F1F5F9"/>
-                </a:solidFill>
-                <a:latin typeface="Arial"/>
-              </a:rPr>
-              <a:t>Live at scale.  </a:t>
-            </a:r>
-            <a:r>
-              <a:rPr sz="1800">
-                <a:solidFill>
-                  <a:srgbClr val="ADBACC"/>
-                </a:solidFill>
-                <a:latin typeface="Arial"/>
-              </a:rPr>
-              <a:t>46 real npm packages forecasted through Sybilion: 18 routed to a human, 28 auto-cleared.</a:t>
-            </a:r>
-          </a:p>
-          <a:p>
-            <a:pPr>
-              <a:lnSpc>
-                <a:spcPct val="105000"/>
-              </a:lnSpc>
-              <a:spcAft>
-                <a:spcPts val="1100"/>
-              </a:spcAft>
-            </a:pPr>
-            <a:r>
-              <a:rPr sz="1800" b="1">
-                <a:solidFill>
-                  <a:srgbClr val="34D399"/>
-                </a:solidFill>
-                <a:latin typeface="Arial"/>
-              </a:rPr>
-              <a:t>▪  </a:t>
-            </a:r>
-            <a:r>
-              <a:rPr sz="1800" b="1">
-                <a:solidFill>
-                  <a:srgbClr val="F1F5F9"/>
-                </a:solidFill>
-                <a:latin typeface="Arial"/>
-              </a:rPr>
-              <a:t>Schema-valid auditor.  </a:t>
-            </a:r>
-            <a:r>
-              <a:rPr sz="1800">
-                <a:solidFill>
-                  <a:srgbClr val="ADBACC"/>
-                </a:solidFill>
-                <a:latin typeface="Arial"/>
-              </a:rPr>
-              <a:t>Valid every time on held-out dossiers, 94 percent narration fidelity, where the untuned base rambles.</a:t>
+              <a:t>Sybilion says the domain is yours. We kept what the forecast earned (trajectory ranking), gated what it could not (the full audit pipeline owns the verdict), and conceded the rest with the data.</a:t>
             </a:r>
           </a:p>
         </p:txBody>
@@ -5019,307 +4812,6 @@
         </p:nvSpPr>
         <p:spPr>
           <a:xfrm>
-            <a:off x="502920" y="640080"/>
-            <a:ext cx="82296" cy="457200"/>
-          </a:xfrm>
-          <a:prstGeom prst="rect">
-            <a:avLst/>
-          </a:prstGeom>
-          <a:solidFill>
-            <a:srgbClr val="34D399"/>
-          </a:solidFill>
-          <a:ln>
-            <a:noFill/>
-          </a:ln>
-          <a:effectLst/>
-        </p:spPr>
-        <p:style>
-          <a:lnRef idx="1">
-            <a:schemeClr val="accent1"/>
-          </a:lnRef>
-          <a:fillRef idx="3">
-            <a:schemeClr val="accent1"/>
-          </a:fillRef>
-          <a:effectRef idx="2">
-            <a:schemeClr val="accent1"/>
-          </a:effectRef>
-          <a:fontRef idx="minor">
-            <a:schemeClr val="lt1"/>
-          </a:fontRef>
-        </p:style>
-        <p:txBody>
-          <a:bodyPr rtlCol="0" anchor="ctr"/>
-          <a:lstStyle/>
-          <a:p>
-            <a:pPr algn="ctr"/>
-          </a:p>
-        </p:txBody>
-      </p:sp>
-      <p:sp>
-        <p:nvSpPr>
-          <p:cNvPr id="4" name="TextBox 3"/>
-          <p:cNvSpPr txBox="1"/>
-          <p:nvPr/>
-        </p:nvSpPr>
-        <p:spPr>
-          <a:xfrm>
-            <a:off x="731520" y="566928"/>
-            <a:ext cx="10058400" cy="365760"/>
-          </a:xfrm>
-          <a:prstGeom prst="rect">
-            <a:avLst/>
-          </a:prstGeom>
-          <a:noFill/>
-        </p:spPr>
-        <p:txBody>
-          <a:bodyPr wrap="square" anchor="t">
-            <a:spAutoFit/>
-          </a:bodyPr>
-          <a:lstStyle/>
-          <a:p>
-            <a:pPr algn="l">
-              <a:lnSpc>
-                <a:spcPct val="100000"/>
-              </a:lnSpc>
-            </a:pPr>
-            <a:r>
-              <a:rPr sz="1300" b="1">
-                <a:solidFill>
-                  <a:srgbClr val="34D399"/>
-                </a:solidFill>
-                <a:latin typeface="Consolas"/>
-              </a:rPr>
-              <a:t>CLOSE</a:t>
-            </a:r>
-          </a:p>
-        </p:txBody>
-      </p:sp>
-      <p:sp>
-        <p:nvSpPr>
-          <p:cNvPr id="5" name="TextBox 4"/>
-          <p:cNvSpPr txBox="1"/>
-          <p:nvPr/>
-        </p:nvSpPr>
-        <p:spPr>
-          <a:xfrm>
-            <a:off x="713232" y="1051560"/>
-            <a:ext cx="10698480" cy="1463040"/>
-          </a:xfrm>
-          <a:prstGeom prst="rect">
-            <a:avLst/>
-          </a:prstGeom>
-          <a:noFill/>
-        </p:spPr>
-        <p:txBody>
-          <a:bodyPr wrap="square" anchor="t">
-            <a:spAutoFit/>
-          </a:bodyPr>
-          <a:lstStyle/>
-          <a:p>
-            <a:pPr algn="l">
-              <a:lnSpc>
-                <a:spcPct val="102000"/>
-              </a:lnSpc>
-            </a:pPr>
-            <a:r>
-              <a:rPr sz="3800" b="1">
-                <a:solidFill>
-                  <a:srgbClr val="F1F5F9"/>
-                </a:solidFill>
-                <a:latin typeface="Arial"/>
-              </a:rPr>
-              <a:t>Grow a forecast into a new domain without it lying to you.</a:t>
-            </a:r>
-          </a:p>
-        </p:txBody>
-      </p:sp>
-      <p:sp>
-        <p:nvSpPr>
-          <p:cNvPr id="6" name="TextBox 5"/>
-          <p:cNvSpPr txBox="1"/>
-          <p:nvPr/>
-        </p:nvSpPr>
-        <p:spPr>
-          <a:xfrm>
-            <a:off x="731520" y="2651760"/>
-            <a:ext cx="10698480" cy="3108960"/>
-          </a:xfrm>
-          <a:prstGeom prst="rect">
-            <a:avLst/>
-          </a:prstGeom>
-          <a:noFill/>
-        </p:spPr>
-        <p:txBody>
-          <a:bodyPr wrap="square" anchor="t">
-            <a:spAutoFit/>
-          </a:bodyPr>
-          <a:lstStyle/>
-          <a:p>
-            <a:pPr algn="l">
-              <a:lnSpc>
-                <a:spcPct val="118000"/>
-              </a:lnSpc>
-            </a:pPr>
-            <a:r>
-              <a:rPr sz="2100" b="0">
-                <a:solidFill>
-                  <a:srgbClr val="ADBACC"/>
-                </a:solidFill>
-                <a:latin typeface="Arial"/>
-              </a:rPr>
-              <a:t>Sybilion says the domain is yours. We kept what the forecast earned (trajectory ranking), gated what it could not (the full audit pipeline owns the verdict), and conceded the rest with the data.</a:t>
-            </a:r>
-          </a:p>
-        </p:txBody>
-      </p:sp>
-      <p:sp>
-        <p:nvSpPr>
-          <p:cNvPr id="7" name="TextBox 6"/>
-          <p:cNvSpPr txBox="1"/>
-          <p:nvPr/>
-        </p:nvSpPr>
-        <p:spPr>
-          <a:xfrm>
-            <a:off x="502920" y="6400800"/>
-            <a:ext cx="8229600" cy="365760"/>
-          </a:xfrm>
-          <a:prstGeom prst="rect">
-            <a:avLst/>
-          </a:prstGeom>
-          <a:noFill/>
-        </p:spPr>
-        <p:txBody>
-          <a:bodyPr wrap="square" anchor="t">
-            <a:spAutoFit/>
-          </a:bodyPr>
-          <a:lstStyle/>
-          <a:p>
-            <a:pPr algn="l">
-              <a:lnSpc>
-                <a:spcPct val="100000"/>
-              </a:lnSpc>
-            </a:pPr>
-            <a:r>
-              <a:rPr sz="1000" b="0">
-                <a:solidFill>
-                  <a:srgbClr val="64748B"/>
-                </a:solidFill>
-                <a:latin typeface="Consolas"/>
-              </a:rPr>
-              <a:t>ModuleWarden  ·  Zero-One Hack Vienna 2026  ·  Forecast track</a:t>
-            </a:r>
-          </a:p>
-        </p:txBody>
-      </p:sp>
-      <p:sp>
-        <p:nvSpPr>
-          <p:cNvPr id="8" name="TextBox 7"/>
-          <p:cNvSpPr txBox="1"/>
-          <p:nvPr/>
-        </p:nvSpPr>
-        <p:spPr>
-          <a:xfrm>
-            <a:off x="11155680" y="6400800"/>
-            <a:ext cx="731520" cy="365760"/>
-          </a:xfrm>
-          <a:prstGeom prst="rect">
-            <a:avLst/>
-          </a:prstGeom>
-          <a:noFill/>
-        </p:spPr>
-        <p:txBody>
-          <a:bodyPr wrap="square" anchor="t">
-            <a:spAutoFit/>
-          </a:bodyPr>
-          <a:lstStyle/>
-          <a:p>
-            <a:pPr algn="r">
-              <a:lnSpc>
-                <a:spcPct val="100000"/>
-              </a:lnSpc>
-            </a:pPr>
-            <a:r>
-              <a:rPr sz="1000" b="0">
-                <a:solidFill>
-                  <a:srgbClr val="64748B"/>
-                </a:solidFill>
-                <a:latin typeface="Consolas"/>
-              </a:rPr>
-              <a:t>14</a:t>
-            </a:r>
-          </a:p>
-        </p:txBody>
-      </p:sp>
-    </p:spTree>
-  </p:cSld>
-  <p:clrMapOvr>
-    <a:masterClrMapping/>
-  </p:clrMapOvr>
-</p:sld>
-</file>
-
-<file path=ppt/slides/slide15.xml><?xml version="1.0" encoding="utf-8"?>
-<p:sld xmlns:a="http://schemas.openxmlformats.org/drawingml/2006/main" xmlns:p="http://schemas.openxmlformats.org/presentationml/2006/main" xmlns:r="http://schemas.openxmlformats.org/officeDocument/2006/relationships">
-  <p:cSld>
-    <p:spTree>
-      <p:nvGrpSpPr>
-        <p:cNvPr id="1" name=""/>
-        <p:cNvGrpSpPr/>
-        <p:nvPr/>
-      </p:nvGrpSpPr>
-      <p:grpSpPr/>
-      <p:sp>
-        <p:nvSpPr>
-          <p:cNvPr id="2" name="Rectangle 1"/>
-          <p:cNvSpPr/>
-          <p:nvPr/>
-        </p:nvSpPr>
-        <p:spPr>
-          <a:xfrm>
-            <a:off x="0" y="0"/>
-            <a:ext cx="12191695" cy="6858000"/>
-          </a:xfrm>
-          <a:prstGeom prst="rect">
-            <a:avLst/>
-          </a:prstGeom>
-          <a:solidFill>
-            <a:srgbClr val="070B16"/>
-          </a:solidFill>
-          <a:ln>
-            <a:noFill/>
-          </a:ln>
-          <a:effectLst/>
-        </p:spPr>
-        <p:style>
-          <a:lnRef idx="1">
-            <a:schemeClr val="accent1"/>
-          </a:lnRef>
-          <a:fillRef idx="3">
-            <a:schemeClr val="accent1"/>
-          </a:fillRef>
-          <a:effectRef idx="2">
-            <a:schemeClr val="accent1"/>
-          </a:effectRef>
-          <a:fontRef idx="minor">
-            <a:schemeClr val="lt1"/>
-          </a:fontRef>
-        </p:style>
-        <p:txBody>
-          <a:bodyPr rtlCol="0" anchor="ctr"/>
-          <a:lstStyle/>
-          <a:p>
-            <a:pPr algn="ctr"/>
-          </a:p>
-        </p:txBody>
-      </p:sp>
-      <p:sp>
-        <p:nvSpPr>
-          <p:cNvPr id="3" name="Rectangle 2"/>
-          <p:cNvSpPr/>
-          <p:nvPr/>
-        </p:nvSpPr>
-        <p:spPr>
-          <a:xfrm>
             <a:off x="0" y="3108960"/>
             <a:ext cx="12191695" cy="45720"/>
           </a:xfrm>
@@ -5565,7 +5057,7 @@
                 </a:solidFill>
                 <a:latin typeface="Consolas"/>
               </a:rPr>
-              <a:t>15</a:t>
+              <a:t>14</a:t>
             </a:r>
           </a:p>
         </p:txBody>

</xml_diff>